<commit_message>
Boubacar (1 Oct): new slide text, Gnaly photos renamed and placed, LinkedIn on the pineapple portrait
Co-Authored-By: Claude Opus 5.5 <noreply@anthropic.com>
Claude-Session: https://claude.ai/code/session_014HGzAbxBh54nuyJHG7tse8
</commit_message>
<xml_diff>
--- a/templates/posts/october/01-10-2026-thu-li-boubacar.pptx
+++ b/templates/posts/october/01-10-2026-thu-li-boubacar.pptx
@@ -502,7 +502,7 @@
           <a:lstStyle/>
           <a:p>
             <a:r>
-              <a:t>LinkedIn image. Instagram collab: @tidia.diallo.1 (from Boubacar's reply to Allison) [VERIFY]. Sources: Impact story sheet, Boubacar Tidiane Diallo: https://docs.google.com/spreadsheets/d/10UHLwzJLBQAsmJqmg4hiCQRjBKXPAx7UnOudU-Vsg5U/edit; YouTube: https://www.youtube.com/@boubacartidianediallo; Facebook: https://www.facebook.com/btidja; Photos: sent by Boubacar to Stephanie on WhatsApp, 17 August 2026. [TAG @Stephanie] Send Boubacar the final caption and slides to approve before posting, and confirm he studied on a scholarship. Photo: assets/photo/boubacar/boubacar-compost-pile.jpeg, cropped to landscape: compost pile in the lower half, tree canopy above. The WhatsApp file is 810 x 1080, so this crop is upscaled about 1.5x; ask Boubacar for the original. No text on the photo.</a:t>
+              <a:t>LinkedIn image. Instagram collab: @tidia.diallo.1. Sources: Impact story sheet, Boubacar Tidiane Diallo: https://docs.google.com/spreadsheets/d/10UHLwzJLBQAsmJqmg4hiCQRjBKXPAx7UnOudU-Vsg5U/edit; Email from Boubacar to Allison, 30 September 2026; Instagram: https://www.instagram.com/tidia.diallo.1/; YouTube: https://www.youtube.com/@boubacartidianediallo; Facebook: https://www.facebook.com/btidja; Photos: sent by Boubacar to Stephanie on WhatsApp, 17 August 2026, and to Allison, September 2026. [TAG @Stephanie] Send Boubacar the final caption and slides to approve before posting, and confirm he studied on a scholarship. Photo: assets/photo/boubacar/boubacar-portrait-bananas.jpg, cropped to landscape. The mulched-field photo was the first choice, but it is portrait and any landscape crop cut off his head. No text on the photo.</a:t>
             </a:r>
           </a:p>
         </p:txBody>
@@ -3518,7 +3518,7 @@
       <p:grpSpPr/>
       <p:pic>
         <p:nvPicPr>
-          <p:cNvPr id="2" name="Picture 1" descr="235668641748942098.jpg"/>
+          <p:cNvPr id="2" name="Picture 1" descr="4546009803198993383.jpg"/>
           <p:cNvPicPr>
             <a:picLocks noChangeAspect="1"/>
           </p:cNvPicPr>

</xml_diff>